<commit_message>
docs: review and update all VID documents
PPTX slide 7 status updated (build done), slide 9 nächste Schritte
updated, slide 6 MCS-Prep note vid_broker/pagefile. MD and DOCX:
D: disk init step added, Schicht labels 5->7 fixed for VDA/optimize/
mcs-prep, MCS Prep description updated (Pagefile auf D:, kein NIC-Reset).

Co-Authored-By: Claude Sonnet 4.6 <noreply@anthropic.com>
</commit_message>
<xml_diff>
--- a/VID-Management-Praesentation-Phase1.pptx
+++ b/VID-Management-Praesentation-Phase1.pptx
@@ -7736,7 +7736,7 @@
                   <a:srgbClr val="64748B"/>
                 </a:solidFill>
               </a:rPr>
-              <a:t>Kein Sysprep — MCS verwaltet Identität</a:t>
+              <a:t>Kein Sysprep · Pagefile auf D: (Write-Cache) · vid_broker-aware</a:t>
             </a:r>
             <a:endParaRPr lang="en-US" sz="850" dirty="0"/>
           </a:p>
@@ -8185,7 +8185,7 @@
                   <a:srgbClr val="1E293B"/>
                 </a:solidFill>
               </a:rPr>
-              <a:t>Post-Install: Reg-Tweaks, EDT-BBR, powercfg, CtxUvi</a:t>
+              <a:t>MCS-Prep &amp; vollst. End-to-End-Build ✓ · D: Write-Cache-Disk konfiguriert</a:t>
             </a:r>
             <a:endParaRPr lang="en-US" sz="950" dirty="0"/>
           </a:p>
@@ -8372,7 +8372,7 @@
                   <a:srgbClr val="1E293B"/>
                 </a:solidFill>
               </a:rPr>
-              <a:t>Citrix VDA Exit-Code 6 Debugging (Defender-Block-Hypothese)</a:t>
+              <a:t>Citrix MCS-Katalog aus Master-Image provisionieren</a:t>
             </a:r>
             <a:endParaRPr lang="en-US" sz="950" dirty="0"/>
           </a:p>
@@ -8390,7 +8390,7 @@
                   <a:srgbClr val="1E293B"/>
                 </a:solidFill>
               </a:rPr>
-              <a:t>Manueller Testlauf auf VM (ProcessStartInfo validiert)</a:t>
+              <a:t>MCS-Pilot: VMs starten, VDA-Registrierung validieren</a:t>
             </a:r>
             <a:endParaRPr lang="en-US" sz="950" dirty="0"/>
           </a:p>
@@ -8408,7 +8408,7 @@
                   <a:srgbClr val="1E293B"/>
                 </a:solidFill>
               </a:rPr>
-              <a:t>Komponenten-Namen kalibriert an Installer-Output</a:t>
+              <a:t>D: Write-Cache Disk im MCS-Betrieb validieren (Pagefile auf D:)</a:t>
             </a:r>
             <a:endParaRPr lang="en-US" sz="950" dirty="0"/>
           </a:p>
@@ -8631,7 +8631,7 @@
                   <a:srgbClr val="1E293B"/>
                 </a:solidFill>
               </a:rPr>
-              <a:t>MCS-Prep &amp; Template-Export nach vSphere</a:t>
+              <a:t>Phase-2-Planung: FSLogix + Entra ID Anforderungen</a:t>
             </a:r>
             <a:endParaRPr lang="en-US" sz="950" dirty="0"/>
           </a:p>
@@ -8649,7 +8649,7 @@
                   <a:srgbClr val="1E293B"/>
                 </a:solidFill>
               </a:rPr>
-              <a:t>Erster vollständiger End-to-End-Build</a:t>
+              <a:t>Multi-Hypervisor-Test: XenServer Build (Phase 2)</a:t>
             </a:r>
             <a:endParaRPr lang="en-US" sz="950" dirty="0"/>
           </a:p>
@@ -10279,7 +10279,7 @@
                   <a:srgbClr val="FFFFFF"/>
                 </a:solidFill>
               </a:rPr>
-              <a:t>Manuellen VDA-Testlauf auf Ziel-VM abschließen (Exit-Code validieren)</a:t>
+              <a:t>Citrix MCS-Katalog aus Master-Image provisionieren (Pilot)</a:t>
             </a:r>
             <a:endParaRPr lang="en-US" sz="1200" dirty="0"/>
           </a:p>
@@ -10401,7 +10401,7 @@
                   <a:srgbClr val="FFFFFF"/>
                 </a:solidFill>
               </a:rPr>
-              <a:t>Ersten vollständigen Packer End-to-End-Build durchführen</a:t>
+              <a:t>MCS-Pilot validieren: VM-Start, VDA registriert, Desktop erreichbar</a:t>
             </a:r>
             <a:endParaRPr lang="en-US" sz="1200" dirty="0"/>
           </a:p>
@@ -10523,7 +10523,7 @@
                   <a:srgbClr val="FFFFFF"/>
                 </a:solidFill>
               </a:rPr>
-              <a:t>Citrix MCS-Katalog aus Master-Image provisionieren (Pilot)</a:t>
+              <a:t>Phase-2-Planung: FSLogix + Entra ID Anforderungen aufnehmen</a:t>
             </a:r>
             <a:endParaRPr lang="en-US" sz="1200" dirty="0"/>
           </a:p>
@@ -10645,7 +10645,7 @@
                   <a:srgbClr val="FFFFFF"/>
                 </a:solidFill>
               </a:rPr>
-              <a:t>Phase-2-Planung: FSLogix + Entra ID Anforderungen aufnehmen</a:t>
+              <a:t>D: Write-Cache Disk im MCS-Betrieb validieren (Pagefile auf D:)</a:t>
             </a:r>
             <a:endParaRPr lang="en-US" sz="1200" dirty="0"/>
           </a:p>

</xml_diff>

<commit_message>
docs: Schichten-Terminologie, Arial-Font, xoap.io und Login Enterprise ergaenzt
- L5/L6/L7 -> Schicht 5/6/7 in allen Dokumenten (Schichtentrennung-Abschnitt)
- Schriftart Arial in PPTX (Theme) und DOCX (Styles)
- xoap.io als alternative Image-Automation-Plattform (Kap. 14 / Slide 4)
- Login Enterprise (Login VSI) in DEX-Schicht 8 ergaenzt (Kap. 8.4a / Slide 3+7)

Co-Authored-By: Claude Sonnet 4.6 <noreply@anthropic.com>
</commit_message>
<xml_diff>
--- a/VID-Management-Praesentation-Phase1.pptx
+++ b/VID-Management-Praesentation-Phase1.pptx
@@ -2932,7 +2932,7 @@
                   <a:srgbClr val="FFFFFF"/>
                 </a:solidFill>
               </a:rPr>
-              <a:t>ControlUp · uberagent · Session-Analytics</a:t>
+              <a:t>ControlUp · uberagent · Login Enterprise (VSI) · Session-Analytics</a:t>
             </a:r>
             <a:endParaRPr lang="en-US" sz="800" dirty="0"/>
           </a:p>
@@ -4918,6 +4918,21 @@
             </a:r>
             <a:endParaRPr lang="en-US" sz="950" dirty="0"/>
           </a:p>
+          <a:p>
+            <a:pPr marL="342900" indent="-342900">
+              <a:buSzPct val="100000"/>
+              <a:buChar char="•"/>
+            </a:pPr>
+            <a:r>
+              <a:rPr lang="en-US" sz="950" dirty="0">
+                <a:solidFill>
+                  <a:srgbClr val="38BDF8"/>
+                </a:solidFill>
+              </a:rPr>
+              <a:t>Alt: xoap.io (Multi-Platform)</a:t>
+            </a:r>
+            <a:endParaRPr lang="en-US" sz="950" dirty="0"/>
+          </a:p>
         </p:txBody>
       </p:sp>
       <p:sp>
@@ -9953,6 +9968,24 @@
                   <a:srgbClr val="1E293B"/>
                 </a:solidFill>
               </a:rPr>
+              <a:t>Login Enterprise (VSI) — Baseline-Tests</a:t>
+            </a:r>
+            <a:endParaRPr lang="en-US" sz="950" dirty="0"/>
+          </a:p>
+          <a:p>
+            <a:pPr marL="342900" indent="-342900">
+              <a:spcAft>
+                <a:spcPts val="300"/>
+              </a:spcAft>
+              <a:buSzPct val="100000"/>
+              <a:buChar char="•"/>
+            </a:pPr>
+            <a:r>
+              <a:rPr lang="en-US" sz="950" dirty="0">
+                <a:solidFill>
+                  <a:srgbClr val="1E293B"/>
+                </a:solidFill>
+              </a:rPr>
               <a:t>Multi-Hypervisor-Support</a:t>
             </a:r>
             <a:endParaRPr lang="en-US" sz="950" dirty="0"/>
@@ -11326,7 +11359,7 @@
                   <a:srgbClr val="1E293B"/>
                 </a:solidFill>
               </a:rPr>
-              <a:t>OS (L5), Treiber (L6) und Broker (L7) werden nie vermischt. Einzelne Layer updaten ohne OS-Rebuild.</a:t>
+              <a:t>OS (S5), Treiber (S6) und Broker (S7) nie in denselben Scripts vermischt. Broker-Wechsel (Citrix → AVD) erfordert keine Änderung am S5-Script — obwohl Packer immer die komplette Pipeline durchläuft.</a:t>
             </a:r>
           </a:p>
         </p:txBody>
@@ -11823,7 +11856,7 @@
     </a:clrScheme>
     <a:fontScheme name="Office">
       <a:majorFont>
-        <a:latin typeface="Calibri Light" panose="020F0302020204030204"/>
+        <a:latin typeface="Arial" panose="020B0604020202020204"/>
         <a:ea typeface=""/>
         <a:cs typeface=""/>
         <a:font script="Jpan" typeface="游ゴシック Light"/>
@@ -11875,7 +11908,7 @@
         <a:font script="Tfng" typeface="Ebrima"/>
       </a:majorFont>
       <a:minorFont>
-        <a:latin typeface="Calibri" panose="020F0502020204030204"/>
+        <a:latin typeface="Arial" panose="020B0604020202020204"/>
         <a:ea typeface=""/>
         <a:cs typeface=""/>
         <a:font script="Jpan" typeface="游ゴシック"/>

</xml_diff>

<commit_message>
docs: Layer -> Schicht global ersetzt, OS-Rebuild-Formulierungen korrigiert
- 'Layer' durchgaengig durch 'Schicht' ersetzt (MD, DOCX, PPTX alle Slides)
- 'ohne OS-Rebuild' Formulierungen korrigiert: Packer baut immer die
  vollstaendige Pipeline -- der Wert liegt im unabhaengigen Wechseln der
  Schicht-Scripts, nicht im Ueberspringen des Builds
- DEX-Austauschbarkeit: 'Agent austauschbar ohne OS-Rebuild' -> korrekte
  Formulierung (nur Manifest-Eintrag aendern, andere Schichten unberuehrt)

Co-Authored-By: Claude Sonnet 4.6 <noreply@anthropic.com>
</commit_message>
<xml_diff>
--- a/VID-Management-Praesentation-Phase1.pptx
+++ b/VID-Management-Praesentation-Phase1.pptx
@@ -2265,7 +2265,7 @@
                   <a:srgbClr val="64748B"/>
                 </a:solidFill>
               </a:rPr>
-              <a:t>klar getrennte Layer</a:t>
+              <a:t>klar getrennte Schichten</a:t>
             </a:r>
             <a:endParaRPr lang="en-US" sz="1000" dirty="0"/>
           </a:p>
@@ -2896,7 +2896,7 @@
                   <a:srgbClr val="FFFFFF"/>
                 </a:solidFill>
               </a:rPr>
-              <a:t>Layer 8 — DEX / Monitoring</a:t>
+              <a:t>Schicht 8 — DEX / Monitoring</a:t>
             </a:r>
             <a:endParaRPr lang="en-US" sz="950" dirty="0"/>
           </a:p>
@@ -3054,7 +3054,7 @@
                   <a:srgbClr val="FFFFFF"/>
                 </a:solidFill>
               </a:rPr>
-              <a:t>Layer 7 — Broker + Profil + Apps</a:t>
+              <a:t>Schicht 7 — Broker + Profil + Apps</a:t>
             </a:r>
             <a:endParaRPr lang="en-US" sz="950" dirty="0"/>
           </a:p>
@@ -3273,7 +3273,7 @@
                   <a:srgbClr val="FFFFFF"/>
                 </a:solidFill>
               </a:rPr>
-              <a:t>Layer 6 — Treiber</a:t>
+              <a:t>Schicht 6 — Treiber</a:t>
             </a:r>
             <a:endParaRPr lang="en-US" sz="950" dirty="0"/>
           </a:p>
@@ -3492,7 +3492,7 @@
                   <a:srgbClr val="FFFFFF"/>
                 </a:solidFill>
               </a:rPr>
-              <a:t>Layer 5 — Windows 11 OS</a:t>
+              <a:t>Schicht 5 — Windows 11 OS</a:t>
             </a:r>
             <a:endParaRPr lang="en-US" sz="950" dirty="0"/>
           </a:p>
@@ -3711,7 +3711,7 @@
                   <a:srgbClr val="1E293B"/>
                 </a:solidFill>
               </a:rPr>
-              <a:t>Layer 4 — Virtualisierungsplattform</a:t>
+              <a:t>Schicht 4 — Virtualisierungsplattform</a:t>
             </a:r>
             <a:endParaRPr lang="en-US" sz="950" dirty="0"/>
           </a:p>
@@ -3869,7 +3869,7 @@
                   <a:srgbClr val="1E293B"/>
                 </a:solidFill>
               </a:rPr>
-              <a:t>Layer 3 — Storage</a:t>
+              <a:t>Schicht 3 — Storage</a:t>
             </a:r>
             <a:endParaRPr lang="en-US" sz="950" dirty="0"/>
           </a:p>
@@ -4027,7 +4027,7 @@
                   <a:srgbClr val="1E293B"/>
                 </a:solidFill>
               </a:rPr>
-              <a:t>Layer 2 — Netzwerk</a:t>
+              <a:t>Schicht 2 — Netzwerk</a:t>
             </a:r>
             <a:endParaRPr lang="en-US" sz="950" dirty="0"/>
           </a:p>
@@ -4185,7 +4185,7 @@
                   <a:srgbClr val="1E293B"/>
                 </a:solidFill>
               </a:rPr>
-              <a:t>Layer 1 — Hardware</a:t>
+              <a:t>Schicht 1 — Hardware</a:t>
             </a:r>
             <a:endParaRPr lang="en-US" sz="950" dirty="0"/>
           </a:p>
@@ -4657,7 +4657,7 @@
                   <a:srgbClr val="64748B"/>
                 </a:solidFill>
               </a:rPr>
-              <a:t>VMware Tools im Layer-6-Image</a:t>
+              <a:t>VMware Tools im Schicht 6-Image</a:t>
             </a:r>
             <a:endParaRPr lang="en-US" sz="950" dirty="0"/>
           </a:p>
@@ -4914,7 +4914,7 @@
                   <a:srgbClr val="64748B"/>
                 </a:solidFill>
               </a:rPr>
-              <a:t>PowerShell-Provisioner je Layer</a:t>
+              <a:t>PowerShell-Provisioner je Schicht</a:t>
             </a:r>
             <a:endParaRPr lang="en-US" sz="950" dirty="0"/>
           </a:p>
@@ -5376,7 +5376,7 @@
                   <a:srgbClr val="10B981"/>
                 </a:solidFill>
               </a:rPr>
-              <a:t>Betriebssystem (Layer 5)</a:t>
+              <a:t>Betriebssystem (Schicht 5)</a:t>
             </a:r>
             <a:endParaRPr lang="en-US" sz="1000" dirty="0"/>
           </a:p>
@@ -5443,7 +5443,7 @@
                   <a:srgbClr val="64748B"/>
                 </a:solidFill>
               </a:rPr>
-              <a:t>Domain-Join optional (Layer 5→7)</a:t>
+              <a:t>Domain-Join optional (Schicht 5→7)</a:t>
             </a:r>
             <a:endParaRPr lang="en-US" sz="950" dirty="0"/>
           </a:p>
@@ -5999,7 +5999,7 @@
                   <a:srgbClr val="64748B"/>
                 </a:solidFill>
               </a:rPr>
-              <a:t>Layer 6 — Paravirtual SCSI / VMXNET3</a:t>
+              <a:t>Schicht 6 — Paravirtual SCSI / VMXNET3</a:t>
             </a:r>
             <a:endParaRPr lang="en-US" sz="850" dirty="0"/>
           </a:p>
@@ -7532,7 +7532,7 @@
                   <a:srgbClr val="64748B"/>
                 </a:solidFill>
               </a:rPr>
-              <a:t>Citrix Optimizer — Layer 7a/7b</a:t>
+              <a:t>Citrix Optimizer — Schicht 7a/7b</a:t>
             </a:r>
             <a:endParaRPr lang="en-US" sz="850" dirty="0"/>
           </a:p>
@@ -8092,7 +8092,7 @@
                   <a:srgbClr val="1E293B"/>
                 </a:solidFill>
               </a:rPr>
-              <a:t>VMware Tools (Layer 6)</a:t>
+              <a:t>VMware Tools (Schicht 6)</a:t>
             </a:r>
             <a:endParaRPr lang="en-US" sz="950" dirty="0"/>
           </a:p>
@@ -8610,7 +8610,7 @@
                   <a:srgbClr val="1E293B"/>
                 </a:solidFill>
               </a:rPr>
-              <a:t>App-Installation via apps-manifest.json (Layer 7c)</a:t>
+              <a:t>App-Installation via apps-manifest.json (Schicht 7c)</a:t>
             </a:r>
             <a:endParaRPr lang="en-US" sz="950" dirty="0"/>
           </a:p>
@@ -9134,7 +9134,7 @@
                   <a:srgbClr val="1E293B"/>
                 </a:solidFill>
               </a:rPr>
-              <a:t>Layer 5: W11 Basisimage</a:t>
+              <a:t>Schicht 5: W11 Basisimage</a:t>
             </a:r>
             <a:endParaRPr lang="en-US" sz="950" dirty="0"/>
           </a:p>
@@ -9152,7 +9152,7 @@
                   <a:srgbClr val="1E293B"/>
                 </a:solidFill>
               </a:rPr>
-              <a:t>Layer 6: VMware Tools</a:t>
+              <a:t>Schicht 6: VMware Tools</a:t>
             </a:r>
             <a:endParaRPr lang="en-US" sz="950" dirty="0"/>
           </a:p>
@@ -9170,7 +9170,7 @@
                   <a:srgbClr val="1E293B"/>
                 </a:solidFill>
               </a:rPr>
-              <a:t>Layer 7: Citrix VDA + MCS</a:t>
+              <a:t>Schicht 7: Citrix VDA + MCS</a:t>
             </a:r>
             <a:endParaRPr lang="en-US" sz="950" dirty="0"/>
           </a:p>
@@ -9932,7 +9932,7 @@
                   <a:srgbClr val="1E293B"/>
                 </a:solidFill>
               </a:rPr>
-              <a:t>ControlUp Agent (Layer 8)</a:t>
+              <a:t>ControlUp Agent (Schicht 8)</a:t>
             </a:r>
             <a:endParaRPr lang="en-US" sz="950" dirty="0"/>
           </a:p>
@@ -11105,7 +11105,7 @@
                   <a:srgbClr val="1E293B"/>
                 </a:solidFill>
               </a:rPr>
-              <a:t>Einheitliche OS-Images ohne Ausnahmen. Keine abteilungsspezifischen Sonderpakete auf Layer-5-Ebene.</a:t>
+              <a:t>Einheitliche OS-Images ohne Ausnahmen. Keine abteilungsspezifischen Sonderpakete auf Schicht 5-Ebene.</a:t>
             </a:r>
           </a:p>
         </p:txBody>
@@ -11613,7 +11613,7 @@
                   <a:srgbClr val="1E293B"/>
                 </a:solidFill>
               </a:rPr>
-              <a:t>Ownership pro Layer definiert. Änderungen nur durch dokumentierten Prozess — kein Ad-hoc-Patching.</a:t>
+              <a:t>Ownership pro Schicht definiert. Änderungen nur durch dokumentierten Prozess — kein Ad-hoc-Patching.</a:t>
             </a:r>
           </a:p>
         </p:txBody>

</xml_diff>

<commit_message>
pptx: App Layering aus Roadmap-Slide entfernt
Co-Authored-By: Claude Sonnet 4.6 <noreply@anthropic.com>
</commit_message>
<xml_diff>
--- a/VID-Management-Praesentation-Phase1.pptx
+++ b/VID-Management-Praesentation-Phase1.pptx
@@ -9552,24 +9552,6 @@
                 </a:solidFill>
               </a:rPr>
               <a:t>Microsoft Entra ID (optional)</a:t>
-            </a:r>
-            <a:endParaRPr lang="en-US" sz="950" dirty="0"/>
-          </a:p>
-          <a:p>
-            <a:pPr marL="342900" indent="-342900">
-              <a:spcAft>
-                <a:spcPts val="300"/>
-              </a:spcAft>
-              <a:buSzPct val="100000"/>
-              <a:buChar char="•"/>
-            </a:pPr>
-            <a:r>
-              <a:rPr lang="en-US" sz="950" dirty="0">
-                <a:solidFill>
-                  <a:srgbClr val="1E293B"/>
-                </a:solidFill>
-              </a:rPr>
-              <a:t>App Layering Evaluation</a:t>
             </a:r>
             <a:endParaRPr lang="en-US" sz="950" dirty="0"/>
           </a:p>

</xml_diff>